<commit_message>
fix(presentation): update repository links to https://github.com/MCIT-DEPI/DEPI-PPTX across PPTX, HTML, and README
</commit_message>
<xml_diff>
--- a/TuT_AI_Marketing_Pitch_Deck.pptx
+++ b/TuT_AI_Marketing_Pitch_Deck.pptx
@@ -5669,7 +5669,7 @@
               </a:defRPr>
             </a:pPr>
             <a:r>
-              <a:t>GitHub Repository: https://github.com/AhmdArFa/TuT-AI</a:t>
+              <a:t>GitHub Repository: https://github.com/MCIT-DEPI/DEPI-PPTX</a:t>
             </a:r>
             <a:br/>
             <a:r>
@@ -9925,7 +9925,7 @@
               </a:defRPr>
             </a:pPr>
             <a:r>
-              <a:t>•  All source code versioned on GitHub: AhmdArFa/TuT-AI.</a:t>
+              <a:t>•  All source code versioned on GitHub: MCIT-DEPI/DEPI-PPTX.</a:t>
             </a:r>
           </a:p>
         </p:txBody>

</xml_diff>

<commit_message>
feat(branding): add Ministry of Communications and Information Technology logo across all presentation slides and README, remove cover lead line
</commit_message>
<xml_diff>
--- a/TuT_AI_Marketing_Pitch_Deck.pptx
+++ b/TuT_AI_Marketing_Pitch_Deck.pptx
@@ -3144,16 +3144,40 @@
           </a:p>
         </p:txBody>
       </p:sp>
-      <p:sp>
-        <p:nvSpPr>
-          <p:cNvPr id="3" name="Rectangle 2"/>
+      <p:pic>
+        <p:nvPicPr>
+          <p:cNvPr id="3" name="Picture 2" descr="mcit-logo.png"/>
+          <p:cNvPicPr>
+            <a:picLocks noChangeAspect="1"/>
+          </p:cNvPicPr>
+          <p:nvPr/>
+        </p:nvPicPr>
+        <p:blipFill>
+          <a:blip r:embed="rId2"/>
+          <a:stretch>
+            <a:fillRect/>
+          </a:stretch>
+        </p:blipFill>
+        <p:spPr>
+          <a:xfrm>
+            <a:off x="1097280" y="731520"/>
+            <a:ext cx="1691640" cy="877824"/>
+          </a:xfrm>
+          <a:prstGeom prst="rect">
+            <a:avLst/>
+          </a:prstGeom>
+        </p:spPr>
+      </p:pic>
+      <p:sp>
+        <p:nvSpPr>
+          <p:cNvPr id="4" name="Rectangle 3"/>
           <p:cNvSpPr/>
           <p:nvPr/>
         </p:nvSpPr>
         <p:spPr>
           <a:xfrm>
-            <a:off x="731520" y="1645920"/>
-            <a:ext cx="109728" cy="3474720"/>
+            <a:off x="731520" y="1920240"/>
+            <a:ext cx="109728" cy="3291840"/>
           </a:xfrm>
           <a:prstGeom prst="rect">
             <a:avLst/>
@@ -3189,13 +3213,13 @@
       </p:sp>
       <p:sp>
         <p:nvSpPr>
-          <p:cNvPr id="4" name="TextBox 3"/>
+          <p:cNvPr id="5" name="TextBox 4"/>
           <p:cNvSpPr txBox="1"/>
           <p:nvPr/>
         </p:nvSpPr>
         <p:spPr>
           <a:xfrm>
-            <a:off x="1097280" y="1463040"/>
+            <a:off x="1097280" y="1737360"/>
             <a:ext cx="10058400" cy="3657600"/>
           </a:xfrm>
           <a:prstGeom prst="rect">
@@ -3243,7 +3267,7 @@
           <a:p>
             <a:pPr>
               <a:spcAft>
-                <a:spcPts val="2800"/>
+                <a:spcPts val="1600"/>
               </a:spcAft>
               <a:defRPr sz="1800">
                 <a:solidFill>
@@ -3254,19 +3278,6 @@
             </a:pPr>
             <a:r>
               <a:t>Strategic Pitch Deck — 100% Offline National Intelligence, Deep Summarization, Autonomous Presentations &amp; Vector Infographics</a:t>
-            </a:r>
-          </a:p>
-          <a:p>
-            <a:pPr>
-              <a:defRPr sz="1300" b="1">
-                <a:solidFill>
-                  <a:srgbClr val="F5D673"/>
-                </a:solidFill>
-                <a:latin typeface="Arial"/>
-              </a:defRPr>
-            </a:pPr>
-            <a:r>
-              <a:t>Principal Architect &amp; Project Lead: Ahmed Gamal Sophi Arfa | Under the Supervision of MCIT Leadership</a:t>
             </a:r>
           </a:p>
         </p:txBody>
@@ -3341,7 +3352,7 @@
         <p:spPr>
           <a:xfrm>
             <a:off x="731520" y="365760"/>
-            <a:ext cx="10698480" cy="365760"/>
+            <a:ext cx="8961120" cy="365760"/>
           </a:xfrm>
           <a:prstGeom prst="rect">
             <a:avLst/>
@@ -3377,7 +3388,7 @@
         <p:spPr>
           <a:xfrm>
             <a:off x="731520" y="685800"/>
-            <a:ext cx="10698480" cy="640080"/>
+            <a:ext cx="8961120" cy="640080"/>
           </a:xfrm>
           <a:prstGeom prst="rect">
             <a:avLst/>
@@ -3404,9 +3415,33 @@
           </a:p>
         </p:txBody>
       </p:sp>
-      <p:sp>
-        <p:nvSpPr>
-          <p:cNvPr id="5" name="Rectangle 4"/>
+      <p:pic>
+        <p:nvPicPr>
+          <p:cNvPr id="5" name="Picture 4" descr="mcit-logo.png"/>
+          <p:cNvPicPr>
+            <a:picLocks noChangeAspect="1"/>
+          </p:cNvPicPr>
+          <p:nvPr/>
+        </p:nvPicPr>
+        <p:blipFill>
+          <a:blip r:embed="rId2"/>
+          <a:stretch>
+            <a:fillRect/>
+          </a:stretch>
+        </p:blipFill>
+        <p:spPr>
+          <a:xfrm>
+            <a:off x="10149840" y="384048"/>
+            <a:ext cx="1307592" cy="685800"/>
+          </a:xfrm>
+          <a:prstGeom prst="rect">
+            <a:avLst/>
+          </a:prstGeom>
+        </p:spPr>
+      </p:pic>
+      <p:sp>
+        <p:nvSpPr>
+          <p:cNvPr id="6" name="Rectangle 5"/>
           <p:cNvSpPr/>
           <p:nvPr/>
         </p:nvSpPr>
@@ -3449,7 +3484,7 @@
       </p:sp>
       <p:sp>
         <p:nvSpPr>
-          <p:cNvPr id="6" name="Rounded Rectangle 5"/>
+          <p:cNvPr id="7" name="Rounded Rectangle 6"/>
           <p:cNvSpPr/>
           <p:nvPr/>
         </p:nvSpPr>
@@ -3555,7 +3590,7 @@
       </p:sp>
       <p:sp>
         <p:nvSpPr>
-          <p:cNvPr id="7" name="Rounded Rectangle 6"/>
+          <p:cNvPr id="8" name="Rounded Rectangle 7"/>
           <p:cNvSpPr/>
           <p:nvPr/>
         </p:nvSpPr>
@@ -3661,7 +3696,7 @@
       </p:sp>
       <p:sp>
         <p:nvSpPr>
-          <p:cNvPr id="8" name="Rounded Rectangle 7"/>
+          <p:cNvPr id="9" name="Rounded Rectangle 8"/>
           <p:cNvSpPr/>
           <p:nvPr/>
         </p:nvSpPr>
@@ -3767,7 +3802,7 @@
       </p:sp>
       <p:sp>
         <p:nvSpPr>
-          <p:cNvPr id="9" name="Rounded Rectangle 8"/>
+          <p:cNvPr id="10" name="Rounded Rectangle 9"/>
           <p:cNvSpPr/>
           <p:nvPr/>
         </p:nvSpPr>
@@ -3941,7 +3976,7 @@
         <p:spPr>
           <a:xfrm>
             <a:off x="731520" y="365760"/>
-            <a:ext cx="10698480" cy="365760"/>
+            <a:ext cx="8961120" cy="365760"/>
           </a:xfrm>
           <a:prstGeom prst="rect">
             <a:avLst/>
@@ -3977,7 +4012,7 @@
         <p:spPr>
           <a:xfrm>
             <a:off x="731520" y="685800"/>
-            <a:ext cx="10698480" cy="640080"/>
+            <a:ext cx="8961120" cy="640080"/>
           </a:xfrm>
           <a:prstGeom prst="rect">
             <a:avLst/>
@@ -4004,9 +4039,33 @@
           </a:p>
         </p:txBody>
       </p:sp>
-      <p:sp>
-        <p:nvSpPr>
-          <p:cNvPr id="5" name="Rectangle 4"/>
+      <p:pic>
+        <p:nvPicPr>
+          <p:cNvPr id="5" name="Picture 4" descr="mcit-logo.png"/>
+          <p:cNvPicPr>
+            <a:picLocks noChangeAspect="1"/>
+          </p:cNvPicPr>
+          <p:nvPr/>
+        </p:nvPicPr>
+        <p:blipFill>
+          <a:blip r:embed="rId2"/>
+          <a:stretch>
+            <a:fillRect/>
+          </a:stretch>
+        </p:blipFill>
+        <p:spPr>
+          <a:xfrm>
+            <a:off x="10149840" y="384048"/>
+            <a:ext cx="1307592" cy="685800"/>
+          </a:xfrm>
+          <a:prstGeom prst="rect">
+            <a:avLst/>
+          </a:prstGeom>
+        </p:spPr>
+      </p:pic>
+      <p:sp>
+        <p:nvSpPr>
+          <p:cNvPr id="6" name="Rectangle 5"/>
           <p:cNvSpPr/>
           <p:nvPr/>
         </p:nvSpPr>
@@ -4049,7 +4108,7 @@
       </p:sp>
       <p:sp>
         <p:nvSpPr>
-          <p:cNvPr id="6" name="Rounded Rectangle 5"/>
+          <p:cNvPr id="7" name="Rounded Rectangle 6"/>
           <p:cNvSpPr/>
           <p:nvPr/>
         </p:nvSpPr>
@@ -4187,7 +4246,7 @@
       </p:sp>
       <p:sp>
         <p:nvSpPr>
-          <p:cNvPr id="7" name="Rounded Rectangle 6"/>
+          <p:cNvPr id="8" name="Rounded Rectangle 7"/>
           <p:cNvSpPr/>
           <p:nvPr/>
         </p:nvSpPr>
@@ -4325,7 +4384,7 @@
       </p:sp>
       <p:sp>
         <p:nvSpPr>
-          <p:cNvPr id="8" name="Rounded Rectangle 7"/>
+          <p:cNvPr id="9" name="Rounded Rectangle 8"/>
           <p:cNvSpPr/>
           <p:nvPr/>
         </p:nvSpPr>
@@ -4531,7 +4590,7 @@
         <p:spPr>
           <a:xfrm>
             <a:off x="731520" y="365760"/>
-            <a:ext cx="10698480" cy="365760"/>
+            <a:ext cx="8961120" cy="365760"/>
           </a:xfrm>
           <a:prstGeom prst="rect">
             <a:avLst/>
@@ -4567,7 +4626,7 @@
         <p:spPr>
           <a:xfrm>
             <a:off x="731520" y="685800"/>
-            <a:ext cx="10698480" cy="640080"/>
+            <a:ext cx="8961120" cy="640080"/>
           </a:xfrm>
           <a:prstGeom prst="rect">
             <a:avLst/>
@@ -4594,9 +4653,33 @@
           </a:p>
         </p:txBody>
       </p:sp>
-      <p:sp>
-        <p:nvSpPr>
-          <p:cNvPr id="5" name="Rectangle 4"/>
+      <p:pic>
+        <p:nvPicPr>
+          <p:cNvPr id="5" name="Picture 4" descr="mcit-logo.png"/>
+          <p:cNvPicPr>
+            <a:picLocks noChangeAspect="1"/>
+          </p:cNvPicPr>
+          <p:nvPr/>
+        </p:nvPicPr>
+        <p:blipFill>
+          <a:blip r:embed="rId2"/>
+          <a:stretch>
+            <a:fillRect/>
+          </a:stretch>
+        </p:blipFill>
+        <p:spPr>
+          <a:xfrm>
+            <a:off x="10149840" y="384048"/>
+            <a:ext cx="1307592" cy="685800"/>
+          </a:xfrm>
+          <a:prstGeom prst="rect">
+            <a:avLst/>
+          </a:prstGeom>
+        </p:spPr>
+      </p:pic>
+      <p:sp>
+        <p:nvSpPr>
+          <p:cNvPr id="6" name="Rectangle 5"/>
           <p:cNvSpPr/>
           <p:nvPr/>
         </p:nvSpPr>
@@ -4639,7 +4722,7 @@
       </p:sp>
       <p:sp>
         <p:nvSpPr>
-          <p:cNvPr id="6" name="Rounded Rectangle 5"/>
+          <p:cNvPr id="7" name="Rounded Rectangle 6"/>
           <p:cNvSpPr/>
           <p:nvPr/>
         </p:nvSpPr>
@@ -4745,7 +4828,7 @@
       </p:sp>
       <p:sp>
         <p:nvSpPr>
-          <p:cNvPr id="7" name="Rounded Rectangle 6"/>
+          <p:cNvPr id="8" name="Rounded Rectangle 7"/>
           <p:cNvSpPr/>
           <p:nvPr/>
         </p:nvSpPr>
@@ -4851,7 +4934,7 @@
       </p:sp>
       <p:sp>
         <p:nvSpPr>
-          <p:cNvPr id="8" name="Rounded Rectangle 7"/>
+          <p:cNvPr id="9" name="Rounded Rectangle 8"/>
           <p:cNvSpPr/>
           <p:nvPr/>
         </p:nvSpPr>
@@ -4957,7 +5040,7 @@
       </p:sp>
       <p:sp>
         <p:nvSpPr>
-          <p:cNvPr id="9" name="Rounded Rectangle 8"/>
+          <p:cNvPr id="10" name="Rounded Rectangle 9"/>
           <p:cNvSpPr/>
           <p:nvPr/>
         </p:nvSpPr>
@@ -5131,7 +5214,7 @@
         <p:spPr>
           <a:xfrm>
             <a:off x="731520" y="365760"/>
-            <a:ext cx="10698480" cy="365760"/>
+            <a:ext cx="8961120" cy="365760"/>
           </a:xfrm>
           <a:prstGeom prst="rect">
             <a:avLst/>
@@ -5167,7 +5250,7 @@
         <p:spPr>
           <a:xfrm>
             <a:off x="731520" y="685800"/>
-            <a:ext cx="10698480" cy="640080"/>
+            <a:ext cx="8961120" cy="640080"/>
           </a:xfrm>
           <a:prstGeom prst="rect">
             <a:avLst/>
@@ -5194,9 +5277,33 @@
           </a:p>
         </p:txBody>
       </p:sp>
-      <p:sp>
-        <p:nvSpPr>
-          <p:cNvPr id="5" name="Rectangle 4"/>
+      <p:pic>
+        <p:nvPicPr>
+          <p:cNvPr id="5" name="Picture 4" descr="mcit-logo.png"/>
+          <p:cNvPicPr>
+            <a:picLocks noChangeAspect="1"/>
+          </p:cNvPicPr>
+          <p:nvPr/>
+        </p:nvPicPr>
+        <p:blipFill>
+          <a:blip r:embed="rId2"/>
+          <a:stretch>
+            <a:fillRect/>
+          </a:stretch>
+        </p:blipFill>
+        <p:spPr>
+          <a:xfrm>
+            <a:off x="10149840" y="384048"/>
+            <a:ext cx="1307592" cy="685800"/>
+          </a:xfrm>
+          <a:prstGeom prst="rect">
+            <a:avLst/>
+          </a:prstGeom>
+        </p:spPr>
+      </p:pic>
+      <p:sp>
+        <p:nvSpPr>
+          <p:cNvPr id="6" name="Rectangle 5"/>
           <p:cNvSpPr/>
           <p:nvPr/>
         </p:nvSpPr>
@@ -5239,7 +5346,7 @@
       </p:sp>
       <p:sp>
         <p:nvSpPr>
-          <p:cNvPr id="6" name="Rounded Rectangle 5"/>
+          <p:cNvPr id="7" name="Rounded Rectangle 6"/>
           <p:cNvSpPr/>
           <p:nvPr/>
         </p:nvSpPr>
@@ -5361,7 +5468,7 @@
       </p:sp>
       <p:sp>
         <p:nvSpPr>
-          <p:cNvPr id="7" name="Rounded Rectangle 6"/>
+          <p:cNvPr id="8" name="Rounded Rectangle 7"/>
           <p:cNvSpPr/>
           <p:nvPr/>
         </p:nvSpPr>
@@ -5590,15 +5697,39 @@
           </a:p>
         </p:txBody>
       </p:sp>
-      <p:sp>
-        <p:nvSpPr>
-          <p:cNvPr id="3" name="TextBox 2"/>
+      <p:pic>
+        <p:nvPicPr>
+          <p:cNvPr id="3" name="Picture 2" descr="mcit-logo.png"/>
+          <p:cNvPicPr>
+            <a:picLocks noChangeAspect="1"/>
+          </p:cNvPicPr>
+          <p:nvPr/>
+        </p:nvPicPr>
+        <p:blipFill>
+          <a:blip r:embed="rId2"/>
+          <a:stretch>
+            <a:fillRect/>
+          </a:stretch>
+        </p:blipFill>
+        <p:spPr>
+          <a:xfrm>
+            <a:off x="5230368" y="548640"/>
+            <a:ext cx="1719072" cy="896112"/>
+          </a:xfrm>
+          <a:prstGeom prst="rect">
+            <a:avLst/>
+          </a:prstGeom>
+        </p:spPr>
+      </p:pic>
+      <p:sp>
+        <p:nvSpPr>
+          <p:cNvPr id="4" name="TextBox 3"/>
           <p:cNvSpPr txBox="1"/>
           <p:nvPr/>
         </p:nvSpPr>
         <p:spPr>
           <a:xfrm>
-            <a:off x="1371600" y="1371600"/>
+            <a:off x="1371600" y="1554480"/>
             <a:ext cx="9445752" cy="4114800"/>
           </a:xfrm>
           <a:prstGeom prst="rect">
@@ -5748,7 +5879,7 @@
         <p:spPr>
           <a:xfrm>
             <a:off x="731520" y="365760"/>
-            <a:ext cx="10698480" cy="365760"/>
+            <a:ext cx="8961120" cy="365760"/>
           </a:xfrm>
           <a:prstGeom prst="rect">
             <a:avLst/>
@@ -5784,7 +5915,7 @@
         <p:spPr>
           <a:xfrm>
             <a:off x="731520" y="685800"/>
-            <a:ext cx="10698480" cy="640080"/>
+            <a:ext cx="8961120" cy="640080"/>
           </a:xfrm>
           <a:prstGeom prst="rect">
             <a:avLst/>
@@ -5811,9 +5942,33 @@
           </a:p>
         </p:txBody>
       </p:sp>
-      <p:sp>
-        <p:nvSpPr>
-          <p:cNvPr id="5" name="Rectangle 4"/>
+      <p:pic>
+        <p:nvPicPr>
+          <p:cNvPr id="5" name="Picture 4" descr="mcit-logo.png"/>
+          <p:cNvPicPr>
+            <a:picLocks noChangeAspect="1"/>
+          </p:cNvPicPr>
+          <p:nvPr/>
+        </p:nvPicPr>
+        <p:blipFill>
+          <a:blip r:embed="rId2"/>
+          <a:stretch>
+            <a:fillRect/>
+          </a:stretch>
+        </p:blipFill>
+        <p:spPr>
+          <a:xfrm>
+            <a:off x="10149840" y="384048"/>
+            <a:ext cx="1307592" cy="685800"/>
+          </a:xfrm>
+          <a:prstGeom prst="rect">
+            <a:avLst/>
+          </a:prstGeom>
+        </p:spPr>
+      </p:pic>
+      <p:sp>
+        <p:nvSpPr>
+          <p:cNvPr id="6" name="Rectangle 5"/>
           <p:cNvSpPr/>
           <p:nvPr/>
         </p:nvSpPr>
@@ -5856,7 +6011,7 @@
       </p:sp>
       <p:sp>
         <p:nvSpPr>
-          <p:cNvPr id="6" name="Rounded Rectangle 5"/>
+          <p:cNvPr id="7" name="Rounded Rectangle 6"/>
           <p:cNvSpPr/>
           <p:nvPr/>
         </p:nvSpPr>
@@ -5994,7 +6149,7 @@
       </p:sp>
       <p:sp>
         <p:nvSpPr>
-          <p:cNvPr id="7" name="Rounded Rectangle 6"/>
+          <p:cNvPr id="8" name="Rounded Rectangle 7"/>
           <p:cNvSpPr/>
           <p:nvPr/>
         </p:nvSpPr>
@@ -6132,7 +6287,7 @@
       </p:sp>
       <p:sp>
         <p:nvSpPr>
-          <p:cNvPr id="8" name="Rounded Rectangle 7"/>
+          <p:cNvPr id="9" name="Rounded Rectangle 8"/>
           <p:cNvSpPr/>
           <p:nvPr/>
         </p:nvSpPr>
@@ -6338,7 +6493,7 @@
         <p:spPr>
           <a:xfrm>
             <a:off x="731520" y="365760"/>
-            <a:ext cx="10698480" cy="365760"/>
+            <a:ext cx="8961120" cy="365760"/>
           </a:xfrm>
           <a:prstGeom prst="rect">
             <a:avLst/>
@@ -6374,7 +6529,7 @@
         <p:spPr>
           <a:xfrm>
             <a:off x="731520" y="685800"/>
-            <a:ext cx="10698480" cy="640080"/>
+            <a:ext cx="8961120" cy="640080"/>
           </a:xfrm>
           <a:prstGeom prst="rect">
             <a:avLst/>
@@ -6401,9 +6556,33 @@
           </a:p>
         </p:txBody>
       </p:sp>
-      <p:sp>
-        <p:nvSpPr>
-          <p:cNvPr id="5" name="Rectangle 4"/>
+      <p:pic>
+        <p:nvPicPr>
+          <p:cNvPr id="5" name="Picture 4" descr="mcit-logo.png"/>
+          <p:cNvPicPr>
+            <a:picLocks noChangeAspect="1"/>
+          </p:cNvPicPr>
+          <p:nvPr/>
+        </p:nvPicPr>
+        <p:blipFill>
+          <a:blip r:embed="rId2"/>
+          <a:stretch>
+            <a:fillRect/>
+          </a:stretch>
+        </p:blipFill>
+        <p:spPr>
+          <a:xfrm>
+            <a:off x="10149840" y="384048"/>
+            <a:ext cx="1307592" cy="685800"/>
+          </a:xfrm>
+          <a:prstGeom prst="rect">
+            <a:avLst/>
+          </a:prstGeom>
+        </p:spPr>
+      </p:pic>
+      <p:sp>
+        <p:nvSpPr>
+          <p:cNvPr id="6" name="Rectangle 5"/>
           <p:cNvSpPr/>
           <p:nvPr/>
         </p:nvSpPr>
@@ -6446,7 +6625,7 @@
       </p:sp>
       <p:sp>
         <p:nvSpPr>
-          <p:cNvPr id="6" name="Rounded Rectangle 5"/>
+          <p:cNvPr id="7" name="Rounded Rectangle 6"/>
           <p:cNvSpPr/>
           <p:nvPr/>
         </p:nvSpPr>
@@ -6584,7 +6763,7 @@
       </p:sp>
       <p:sp>
         <p:nvSpPr>
-          <p:cNvPr id="7" name="Rounded Rectangle 6"/>
+          <p:cNvPr id="8" name="Rounded Rectangle 7"/>
           <p:cNvSpPr/>
           <p:nvPr/>
         </p:nvSpPr>
@@ -6722,7 +6901,7 @@
       </p:sp>
       <p:sp>
         <p:nvSpPr>
-          <p:cNvPr id="8" name="Rounded Rectangle 7"/>
+          <p:cNvPr id="9" name="Rounded Rectangle 8"/>
           <p:cNvSpPr/>
           <p:nvPr/>
         </p:nvSpPr>
@@ -6928,7 +7107,7 @@
         <p:spPr>
           <a:xfrm>
             <a:off x="731520" y="365760"/>
-            <a:ext cx="10698480" cy="365760"/>
+            <a:ext cx="8961120" cy="365760"/>
           </a:xfrm>
           <a:prstGeom prst="rect">
             <a:avLst/>
@@ -6964,7 +7143,7 @@
         <p:spPr>
           <a:xfrm>
             <a:off x="731520" y="685800"/>
-            <a:ext cx="10698480" cy="640080"/>
+            <a:ext cx="8961120" cy="640080"/>
           </a:xfrm>
           <a:prstGeom prst="rect">
             <a:avLst/>
@@ -6991,9 +7170,33 @@
           </a:p>
         </p:txBody>
       </p:sp>
-      <p:sp>
-        <p:nvSpPr>
-          <p:cNvPr id="5" name="Rectangle 4"/>
+      <p:pic>
+        <p:nvPicPr>
+          <p:cNvPr id="5" name="Picture 4" descr="mcit-logo.png"/>
+          <p:cNvPicPr>
+            <a:picLocks noChangeAspect="1"/>
+          </p:cNvPicPr>
+          <p:nvPr/>
+        </p:nvPicPr>
+        <p:blipFill>
+          <a:blip r:embed="rId2"/>
+          <a:stretch>
+            <a:fillRect/>
+          </a:stretch>
+        </p:blipFill>
+        <p:spPr>
+          <a:xfrm>
+            <a:off x="10149840" y="384048"/>
+            <a:ext cx="1307592" cy="685800"/>
+          </a:xfrm>
+          <a:prstGeom prst="rect">
+            <a:avLst/>
+          </a:prstGeom>
+        </p:spPr>
+      </p:pic>
+      <p:sp>
+        <p:nvSpPr>
+          <p:cNvPr id="6" name="Rectangle 5"/>
           <p:cNvSpPr/>
           <p:nvPr/>
         </p:nvSpPr>
@@ -7036,7 +7239,7 @@
       </p:sp>
       <p:sp>
         <p:nvSpPr>
-          <p:cNvPr id="6" name="Rounded Rectangle 5"/>
+          <p:cNvPr id="7" name="Rounded Rectangle 6"/>
           <p:cNvSpPr/>
           <p:nvPr/>
         </p:nvSpPr>
@@ -7174,7 +7377,7 @@
       </p:sp>
       <p:sp>
         <p:nvSpPr>
-          <p:cNvPr id="7" name="Rounded Rectangle 6"/>
+          <p:cNvPr id="8" name="Rounded Rectangle 7"/>
           <p:cNvSpPr/>
           <p:nvPr/>
         </p:nvSpPr>
@@ -7380,7 +7583,7 @@
         <p:spPr>
           <a:xfrm>
             <a:off x="731520" y="365760"/>
-            <a:ext cx="10698480" cy="365760"/>
+            <a:ext cx="8961120" cy="365760"/>
           </a:xfrm>
           <a:prstGeom prst="rect">
             <a:avLst/>
@@ -7416,7 +7619,7 @@
         <p:spPr>
           <a:xfrm>
             <a:off x="731520" y="685800"/>
-            <a:ext cx="10698480" cy="640080"/>
+            <a:ext cx="8961120" cy="640080"/>
           </a:xfrm>
           <a:prstGeom prst="rect">
             <a:avLst/>
@@ -7443,9 +7646,33 @@
           </a:p>
         </p:txBody>
       </p:sp>
-      <p:sp>
-        <p:nvSpPr>
-          <p:cNvPr id="5" name="Rectangle 4"/>
+      <p:pic>
+        <p:nvPicPr>
+          <p:cNvPr id="5" name="Picture 4" descr="mcit-logo.png"/>
+          <p:cNvPicPr>
+            <a:picLocks noChangeAspect="1"/>
+          </p:cNvPicPr>
+          <p:nvPr/>
+        </p:nvPicPr>
+        <p:blipFill>
+          <a:blip r:embed="rId2"/>
+          <a:stretch>
+            <a:fillRect/>
+          </a:stretch>
+        </p:blipFill>
+        <p:spPr>
+          <a:xfrm>
+            <a:off x="10149840" y="384048"/>
+            <a:ext cx="1307592" cy="685800"/>
+          </a:xfrm>
+          <a:prstGeom prst="rect">
+            <a:avLst/>
+          </a:prstGeom>
+        </p:spPr>
+      </p:pic>
+      <p:sp>
+        <p:nvSpPr>
+          <p:cNvPr id="6" name="Rectangle 5"/>
           <p:cNvSpPr/>
           <p:nvPr/>
         </p:nvSpPr>
@@ -7488,7 +7715,7 @@
       </p:sp>
       <p:sp>
         <p:nvSpPr>
-          <p:cNvPr id="6" name="Rounded Rectangle 5"/>
+          <p:cNvPr id="7" name="Rounded Rectangle 6"/>
           <p:cNvSpPr/>
           <p:nvPr/>
         </p:nvSpPr>
@@ -7626,7 +7853,7 @@
       </p:sp>
       <p:sp>
         <p:nvSpPr>
-          <p:cNvPr id="7" name="Rounded Rectangle 6"/>
+          <p:cNvPr id="8" name="Rounded Rectangle 7"/>
           <p:cNvSpPr/>
           <p:nvPr/>
         </p:nvSpPr>
@@ -7832,7 +8059,7 @@
         <p:spPr>
           <a:xfrm>
             <a:off x="731520" y="365760"/>
-            <a:ext cx="10698480" cy="365760"/>
+            <a:ext cx="8961120" cy="365760"/>
           </a:xfrm>
           <a:prstGeom prst="rect">
             <a:avLst/>
@@ -7868,7 +8095,7 @@
         <p:spPr>
           <a:xfrm>
             <a:off x="731520" y="685800"/>
-            <a:ext cx="10698480" cy="640080"/>
+            <a:ext cx="8961120" cy="640080"/>
           </a:xfrm>
           <a:prstGeom prst="rect">
             <a:avLst/>
@@ -7895,9 +8122,33 @@
           </a:p>
         </p:txBody>
       </p:sp>
-      <p:sp>
-        <p:nvSpPr>
-          <p:cNvPr id="5" name="Rectangle 4"/>
+      <p:pic>
+        <p:nvPicPr>
+          <p:cNvPr id="5" name="Picture 4" descr="mcit-logo.png"/>
+          <p:cNvPicPr>
+            <a:picLocks noChangeAspect="1"/>
+          </p:cNvPicPr>
+          <p:nvPr/>
+        </p:nvPicPr>
+        <p:blipFill>
+          <a:blip r:embed="rId2"/>
+          <a:stretch>
+            <a:fillRect/>
+          </a:stretch>
+        </p:blipFill>
+        <p:spPr>
+          <a:xfrm>
+            <a:off x="10149840" y="384048"/>
+            <a:ext cx="1307592" cy="685800"/>
+          </a:xfrm>
+          <a:prstGeom prst="rect">
+            <a:avLst/>
+          </a:prstGeom>
+        </p:spPr>
+      </p:pic>
+      <p:sp>
+        <p:nvSpPr>
+          <p:cNvPr id="6" name="Rectangle 5"/>
           <p:cNvSpPr/>
           <p:nvPr/>
         </p:nvSpPr>
@@ -7940,7 +8191,7 @@
       </p:sp>
       <p:sp>
         <p:nvSpPr>
-          <p:cNvPr id="6" name="Rounded Rectangle 5"/>
+          <p:cNvPr id="7" name="Rounded Rectangle 6"/>
           <p:cNvSpPr/>
           <p:nvPr/>
         </p:nvSpPr>
@@ -8078,7 +8329,7 @@
       </p:sp>
       <p:sp>
         <p:nvSpPr>
-          <p:cNvPr id="7" name="Rounded Rectangle 6"/>
+          <p:cNvPr id="8" name="Rounded Rectangle 7"/>
           <p:cNvSpPr/>
           <p:nvPr/>
         </p:nvSpPr>
@@ -8284,7 +8535,7 @@
         <p:spPr>
           <a:xfrm>
             <a:off x="731520" y="365760"/>
-            <a:ext cx="10698480" cy="365760"/>
+            <a:ext cx="8961120" cy="365760"/>
           </a:xfrm>
           <a:prstGeom prst="rect">
             <a:avLst/>
@@ -8320,7 +8571,7 @@
         <p:spPr>
           <a:xfrm>
             <a:off x="731520" y="685800"/>
-            <a:ext cx="10698480" cy="640080"/>
+            <a:ext cx="8961120" cy="640080"/>
           </a:xfrm>
           <a:prstGeom prst="rect">
             <a:avLst/>
@@ -8347,97 +8598,9 @@
           </a:p>
         </p:txBody>
       </p:sp>
-      <p:sp>
-        <p:nvSpPr>
-          <p:cNvPr id="5" name="Rectangle 4"/>
-          <p:cNvSpPr/>
-          <p:nvPr/>
-        </p:nvSpPr>
-        <p:spPr>
-          <a:xfrm>
-            <a:off x="731520" y="1371600"/>
-            <a:ext cx="10728655" cy="18288"/>
-          </a:xfrm>
-          <a:prstGeom prst="rect">
-            <a:avLst/>
-          </a:prstGeom>
-          <a:solidFill>
-            <a:srgbClr val="D4AF37"/>
-          </a:solidFill>
-          <a:ln>
-            <a:noFill/>
-          </a:ln>
-        </p:spPr>
-        <p:style>
-          <a:lnRef idx="1">
-            <a:schemeClr val="accent1"/>
-          </a:lnRef>
-          <a:fillRef idx="3">
-            <a:schemeClr val="accent1"/>
-          </a:fillRef>
-          <a:effectRef idx="2">
-            <a:schemeClr val="accent1"/>
-          </a:effectRef>
-          <a:fontRef idx="minor">
-            <a:schemeClr val="lt1"/>
-          </a:fontRef>
-        </p:style>
-        <p:txBody>
-          <a:bodyPr rtlCol="0" anchor="ctr"/>
-          <a:lstStyle/>
-          <a:p>
-            <a:pPr algn="ctr"/>
-          </a:p>
-        </p:txBody>
-      </p:sp>
-      <p:sp>
-        <p:nvSpPr>
-          <p:cNvPr id="6" name="Rounded Rectangle 5"/>
-          <p:cNvSpPr/>
-          <p:nvPr/>
-        </p:nvSpPr>
-        <p:spPr>
-          <a:xfrm>
-            <a:off x="676656" y="1728216"/>
-            <a:ext cx="6876288" cy="4114800"/>
-          </a:xfrm>
-          <a:prstGeom prst="roundRect">
-            <a:avLst/>
-          </a:prstGeom>
-          <a:solidFill>
-            <a:srgbClr val="111827"/>
-          </a:solidFill>
-          <a:ln w="19050">
-            <a:solidFill>
-              <a:srgbClr val="D4AF37"/>
-            </a:solidFill>
-          </a:ln>
-        </p:spPr>
-        <p:style>
-          <a:lnRef idx="1">
-            <a:schemeClr val="accent1"/>
-          </a:lnRef>
-          <a:fillRef idx="3">
-            <a:schemeClr val="accent1"/>
-          </a:fillRef>
-          <a:effectRef idx="2">
-            <a:schemeClr val="accent1"/>
-          </a:effectRef>
-          <a:fontRef idx="minor">
-            <a:schemeClr val="lt1"/>
-          </a:fontRef>
-        </p:style>
-        <p:txBody>
-          <a:bodyPr rtlCol="0" anchor="ctr"/>
-          <a:lstStyle/>
-          <a:p>
-            <a:pPr algn="ctr"/>
-          </a:p>
-        </p:txBody>
-      </p:sp>
       <p:pic>
         <p:nvPicPr>
-          <p:cNvPr id="7" name="Picture 6" descr="tut_ui_notebooks.png"/>
+          <p:cNvPr id="5" name="Picture 4" descr="mcit-logo.png"/>
           <p:cNvPicPr>
             <a:picLocks noChangeAspect="1"/>
           </p:cNvPicPr>
@@ -8451,6 +8614,118 @@
         </p:blipFill>
         <p:spPr>
           <a:xfrm>
+            <a:off x="10149840" y="384048"/>
+            <a:ext cx="1307592" cy="685800"/>
+          </a:xfrm>
+          <a:prstGeom prst="rect">
+            <a:avLst/>
+          </a:prstGeom>
+        </p:spPr>
+      </p:pic>
+      <p:sp>
+        <p:nvSpPr>
+          <p:cNvPr id="6" name="Rectangle 5"/>
+          <p:cNvSpPr/>
+          <p:nvPr/>
+        </p:nvSpPr>
+        <p:spPr>
+          <a:xfrm>
+            <a:off x="731520" y="1371600"/>
+            <a:ext cx="10728655" cy="18288"/>
+          </a:xfrm>
+          <a:prstGeom prst="rect">
+            <a:avLst/>
+          </a:prstGeom>
+          <a:solidFill>
+            <a:srgbClr val="D4AF37"/>
+          </a:solidFill>
+          <a:ln>
+            <a:noFill/>
+          </a:ln>
+        </p:spPr>
+        <p:style>
+          <a:lnRef idx="1">
+            <a:schemeClr val="accent1"/>
+          </a:lnRef>
+          <a:fillRef idx="3">
+            <a:schemeClr val="accent1"/>
+          </a:fillRef>
+          <a:effectRef idx="2">
+            <a:schemeClr val="accent1"/>
+          </a:effectRef>
+          <a:fontRef idx="minor">
+            <a:schemeClr val="lt1"/>
+          </a:fontRef>
+        </p:style>
+        <p:txBody>
+          <a:bodyPr rtlCol="0" anchor="ctr"/>
+          <a:lstStyle/>
+          <a:p>
+            <a:pPr algn="ctr"/>
+          </a:p>
+        </p:txBody>
+      </p:sp>
+      <p:sp>
+        <p:nvSpPr>
+          <p:cNvPr id="7" name="Rounded Rectangle 6"/>
+          <p:cNvSpPr/>
+          <p:nvPr/>
+        </p:nvSpPr>
+        <p:spPr>
+          <a:xfrm>
+            <a:off x="676656" y="1728216"/>
+            <a:ext cx="6876288" cy="4114800"/>
+          </a:xfrm>
+          <a:prstGeom prst="roundRect">
+            <a:avLst/>
+          </a:prstGeom>
+          <a:solidFill>
+            <a:srgbClr val="111827"/>
+          </a:solidFill>
+          <a:ln w="19050">
+            <a:solidFill>
+              <a:srgbClr val="D4AF37"/>
+            </a:solidFill>
+          </a:ln>
+        </p:spPr>
+        <p:style>
+          <a:lnRef idx="1">
+            <a:schemeClr val="accent1"/>
+          </a:lnRef>
+          <a:fillRef idx="3">
+            <a:schemeClr val="accent1"/>
+          </a:fillRef>
+          <a:effectRef idx="2">
+            <a:schemeClr val="accent1"/>
+          </a:effectRef>
+          <a:fontRef idx="minor">
+            <a:schemeClr val="lt1"/>
+          </a:fontRef>
+        </p:style>
+        <p:txBody>
+          <a:bodyPr rtlCol="0" anchor="ctr"/>
+          <a:lstStyle/>
+          <a:p>
+            <a:pPr algn="ctr"/>
+          </a:p>
+        </p:txBody>
+      </p:sp>
+      <p:pic>
+        <p:nvPicPr>
+          <p:cNvPr id="8" name="Picture 7" descr="tut_ui_notebooks.png"/>
+          <p:cNvPicPr>
+            <a:picLocks noChangeAspect="1"/>
+          </p:cNvPicPr>
+          <p:nvPr/>
+        </p:nvPicPr>
+        <p:blipFill>
+          <a:blip r:embed="rId3"/>
+          <a:stretch>
+            <a:fillRect/>
+          </a:stretch>
+        </p:blipFill>
+        <p:spPr>
+          <a:xfrm>
             <a:off x="731520" y="1783080"/>
             <a:ext cx="6766560" cy="4005072"/>
           </a:xfrm>
@@ -8461,7 +8736,7 @@
       </p:pic>
       <p:sp>
         <p:nvSpPr>
-          <p:cNvPr id="8" name="Rounded Rectangle 7"/>
+          <p:cNvPr id="9" name="Rounded Rectangle 8"/>
           <p:cNvSpPr/>
           <p:nvPr/>
         </p:nvSpPr>
@@ -8567,7 +8842,7 @@
       </p:sp>
       <p:sp>
         <p:nvSpPr>
-          <p:cNvPr id="9" name="Rounded Rectangle 8"/>
+          <p:cNvPr id="10" name="Rounded Rectangle 9"/>
           <p:cNvSpPr/>
           <p:nvPr/>
         </p:nvSpPr>
@@ -8673,7 +8948,7 @@
       </p:sp>
       <p:sp>
         <p:nvSpPr>
-          <p:cNvPr id="10" name="Rounded Rectangle 9"/>
+          <p:cNvPr id="11" name="Rounded Rectangle 10"/>
           <p:cNvSpPr/>
           <p:nvPr/>
         </p:nvSpPr>
@@ -8847,7 +9122,7 @@
         <p:spPr>
           <a:xfrm>
             <a:off x="731520" y="365760"/>
-            <a:ext cx="10698480" cy="365760"/>
+            <a:ext cx="8961120" cy="365760"/>
           </a:xfrm>
           <a:prstGeom prst="rect">
             <a:avLst/>
@@ -8883,7 +9158,7 @@
         <p:spPr>
           <a:xfrm>
             <a:off x="731520" y="685800"/>
-            <a:ext cx="10698480" cy="640080"/>
+            <a:ext cx="8961120" cy="640080"/>
           </a:xfrm>
           <a:prstGeom prst="rect">
             <a:avLst/>
@@ -8910,97 +9185,9 @@
           </a:p>
         </p:txBody>
       </p:sp>
-      <p:sp>
-        <p:nvSpPr>
-          <p:cNvPr id="5" name="Rectangle 4"/>
-          <p:cNvSpPr/>
-          <p:nvPr/>
-        </p:nvSpPr>
-        <p:spPr>
-          <a:xfrm>
-            <a:off x="731520" y="1371600"/>
-            <a:ext cx="10728655" cy="18288"/>
-          </a:xfrm>
-          <a:prstGeom prst="rect">
-            <a:avLst/>
-          </a:prstGeom>
-          <a:solidFill>
-            <a:srgbClr val="D4AF37"/>
-          </a:solidFill>
-          <a:ln>
-            <a:noFill/>
-          </a:ln>
-        </p:spPr>
-        <p:style>
-          <a:lnRef idx="1">
-            <a:schemeClr val="accent1"/>
-          </a:lnRef>
-          <a:fillRef idx="3">
-            <a:schemeClr val="accent1"/>
-          </a:fillRef>
-          <a:effectRef idx="2">
-            <a:schemeClr val="accent1"/>
-          </a:effectRef>
-          <a:fontRef idx="minor">
-            <a:schemeClr val="lt1"/>
-          </a:fontRef>
-        </p:style>
-        <p:txBody>
-          <a:bodyPr rtlCol="0" anchor="ctr"/>
-          <a:lstStyle/>
-          <a:p>
-            <a:pPr algn="ctr"/>
-          </a:p>
-        </p:txBody>
-      </p:sp>
-      <p:sp>
-        <p:nvSpPr>
-          <p:cNvPr id="6" name="Rounded Rectangle 5"/>
-          <p:cNvSpPr/>
-          <p:nvPr/>
-        </p:nvSpPr>
-        <p:spPr>
-          <a:xfrm>
-            <a:off x="676656" y="1728216"/>
-            <a:ext cx="6876288" cy="4114800"/>
-          </a:xfrm>
-          <a:prstGeom prst="roundRect">
-            <a:avLst/>
-          </a:prstGeom>
-          <a:solidFill>
-            <a:srgbClr val="111827"/>
-          </a:solidFill>
-          <a:ln w="19050">
-            <a:solidFill>
-              <a:srgbClr val="38BDF8"/>
-            </a:solidFill>
-          </a:ln>
-        </p:spPr>
-        <p:style>
-          <a:lnRef idx="1">
-            <a:schemeClr val="accent1"/>
-          </a:lnRef>
-          <a:fillRef idx="3">
-            <a:schemeClr val="accent1"/>
-          </a:fillRef>
-          <a:effectRef idx="2">
-            <a:schemeClr val="accent1"/>
-          </a:effectRef>
-          <a:fontRef idx="minor">
-            <a:schemeClr val="lt1"/>
-          </a:fontRef>
-        </p:style>
-        <p:txBody>
-          <a:bodyPr rtlCol="0" anchor="ctr"/>
-          <a:lstStyle/>
-          <a:p>
-            <a:pPr algn="ctr"/>
-          </a:p>
-        </p:txBody>
-      </p:sp>
       <p:pic>
         <p:nvPicPr>
-          <p:cNvPr id="7" name="Picture 6" descr="tut_ui_agent.png"/>
+          <p:cNvPr id="5" name="Picture 4" descr="mcit-logo.png"/>
           <p:cNvPicPr>
             <a:picLocks noChangeAspect="1"/>
           </p:cNvPicPr>
@@ -9014,6 +9201,118 @@
         </p:blipFill>
         <p:spPr>
           <a:xfrm>
+            <a:off x="10149840" y="384048"/>
+            <a:ext cx="1307592" cy="685800"/>
+          </a:xfrm>
+          <a:prstGeom prst="rect">
+            <a:avLst/>
+          </a:prstGeom>
+        </p:spPr>
+      </p:pic>
+      <p:sp>
+        <p:nvSpPr>
+          <p:cNvPr id="6" name="Rectangle 5"/>
+          <p:cNvSpPr/>
+          <p:nvPr/>
+        </p:nvSpPr>
+        <p:spPr>
+          <a:xfrm>
+            <a:off x="731520" y="1371600"/>
+            <a:ext cx="10728655" cy="18288"/>
+          </a:xfrm>
+          <a:prstGeom prst="rect">
+            <a:avLst/>
+          </a:prstGeom>
+          <a:solidFill>
+            <a:srgbClr val="D4AF37"/>
+          </a:solidFill>
+          <a:ln>
+            <a:noFill/>
+          </a:ln>
+        </p:spPr>
+        <p:style>
+          <a:lnRef idx="1">
+            <a:schemeClr val="accent1"/>
+          </a:lnRef>
+          <a:fillRef idx="3">
+            <a:schemeClr val="accent1"/>
+          </a:fillRef>
+          <a:effectRef idx="2">
+            <a:schemeClr val="accent1"/>
+          </a:effectRef>
+          <a:fontRef idx="minor">
+            <a:schemeClr val="lt1"/>
+          </a:fontRef>
+        </p:style>
+        <p:txBody>
+          <a:bodyPr rtlCol="0" anchor="ctr"/>
+          <a:lstStyle/>
+          <a:p>
+            <a:pPr algn="ctr"/>
+          </a:p>
+        </p:txBody>
+      </p:sp>
+      <p:sp>
+        <p:nvSpPr>
+          <p:cNvPr id="7" name="Rounded Rectangle 6"/>
+          <p:cNvSpPr/>
+          <p:nvPr/>
+        </p:nvSpPr>
+        <p:spPr>
+          <a:xfrm>
+            <a:off x="676656" y="1728216"/>
+            <a:ext cx="6876288" cy="4114800"/>
+          </a:xfrm>
+          <a:prstGeom prst="roundRect">
+            <a:avLst/>
+          </a:prstGeom>
+          <a:solidFill>
+            <a:srgbClr val="111827"/>
+          </a:solidFill>
+          <a:ln w="19050">
+            <a:solidFill>
+              <a:srgbClr val="38BDF8"/>
+            </a:solidFill>
+          </a:ln>
+        </p:spPr>
+        <p:style>
+          <a:lnRef idx="1">
+            <a:schemeClr val="accent1"/>
+          </a:lnRef>
+          <a:fillRef idx="3">
+            <a:schemeClr val="accent1"/>
+          </a:fillRef>
+          <a:effectRef idx="2">
+            <a:schemeClr val="accent1"/>
+          </a:effectRef>
+          <a:fontRef idx="minor">
+            <a:schemeClr val="lt1"/>
+          </a:fontRef>
+        </p:style>
+        <p:txBody>
+          <a:bodyPr rtlCol="0" anchor="ctr"/>
+          <a:lstStyle/>
+          <a:p>
+            <a:pPr algn="ctr"/>
+          </a:p>
+        </p:txBody>
+      </p:sp>
+      <p:pic>
+        <p:nvPicPr>
+          <p:cNvPr id="8" name="Picture 7" descr="tut_ui_agent.png"/>
+          <p:cNvPicPr>
+            <a:picLocks noChangeAspect="1"/>
+          </p:cNvPicPr>
+          <p:nvPr/>
+        </p:nvPicPr>
+        <p:blipFill>
+          <a:blip r:embed="rId3"/>
+          <a:stretch>
+            <a:fillRect/>
+          </a:stretch>
+        </p:blipFill>
+        <p:spPr>
+          <a:xfrm>
             <a:off x="731520" y="1783080"/>
             <a:ext cx="6766560" cy="4005072"/>
           </a:xfrm>
@@ -9024,7 +9323,7 @@
       </p:pic>
       <p:sp>
         <p:nvSpPr>
-          <p:cNvPr id="8" name="Rounded Rectangle 7"/>
+          <p:cNvPr id="9" name="Rounded Rectangle 8"/>
           <p:cNvSpPr/>
           <p:nvPr/>
         </p:nvSpPr>
@@ -9130,7 +9429,7 @@
       </p:sp>
       <p:sp>
         <p:nvSpPr>
-          <p:cNvPr id="9" name="Rounded Rectangle 8"/>
+          <p:cNvPr id="10" name="Rounded Rectangle 9"/>
           <p:cNvSpPr/>
           <p:nvPr/>
         </p:nvSpPr>
@@ -9236,7 +9535,7 @@
       </p:sp>
       <p:sp>
         <p:nvSpPr>
-          <p:cNvPr id="10" name="Rounded Rectangle 9"/>
+          <p:cNvPr id="11" name="Rounded Rectangle 10"/>
           <p:cNvSpPr/>
           <p:nvPr/>
         </p:nvSpPr>
@@ -9410,7 +9709,7 @@
         <p:spPr>
           <a:xfrm>
             <a:off x="731520" y="365760"/>
-            <a:ext cx="10698480" cy="365760"/>
+            <a:ext cx="8961120" cy="365760"/>
           </a:xfrm>
           <a:prstGeom prst="rect">
             <a:avLst/>
@@ -9446,7 +9745,7 @@
         <p:spPr>
           <a:xfrm>
             <a:off x="731520" y="685800"/>
-            <a:ext cx="10698480" cy="640080"/>
+            <a:ext cx="8961120" cy="640080"/>
           </a:xfrm>
           <a:prstGeom prst="rect">
             <a:avLst/>
@@ -9473,9 +9772,33 @@
           </a:p>
         </p:txBody>
       </p:sp>
-      <p:sp>
-        <p:nvSpPr>
-          <p:cNvPr id="5" name="Rectangle 4"/>
+      <p:pic>
+        <p:nvPicPr>
+          <p:cNvPr id="5" name="Picture 4" descr="mcit-logo.png"/>
+          <p:cNvPicPr>
+            <a:picLocks noChangeAspect="1"/>
+          </p:cNvPicPr>
+          <p:nvPr/>
+        </p:nvPicPr>
+        <p:blipFill>
+          <a:blip r:embed="rId2"/>
+          <a:stretch>
+            <a:fillRect/>
+          </a:stretch>
+        </p:blipFill>
+        <p:spPr>
+          <a:xfrm>
+            <a:off x="10149840" y="384048"/>
+            <a:ext cx="1307592" cy="685800"/>
+          </a:xfrm>
+          <a:prstGeom prst="rect">
+            <a:avLst/>
+          </a:prstGeom>
+        </p:spPr>
+      </p:pic>
+      <p:sp>
+        <p:nvSpPr>
+          <p:cNvPr id="6" name="Rectangle 5"/>
           <p:cNvSpPr/>
           <p:nvPr/>
         </p:nvSpPr>
@@ -9518,7 +9841,7 @@
       </p:sp>
       <p:sp>
         <p:nvSpPr>
-          <p:cNvPr id="6" name="Rounded Rectangle 5"/>
+          <p:cNvPr id="7" name="Rounded Rectangle 6"/>
           <p:cNvSpPr/>
           <p:nvPr/>
         </p:nvSpPr>
@@ -9656,7 +9979,7 @@
       </p:sp>
       <p:sp>
         <p:nvSpPr>
-          <p:cNvPr id="7" name="Rounded Rectangle 6"/>
+          <p:cNvPr id="8" name="Rounded Rectangle 7"/>
           <p:cNvSpPr/>
           <p:nvPr/>
         </p:nvSpPr>
@@ -9794,7 +10117,7 @@
       </p:sp>
       <p:sp>
         <p:nvSpPr>
-          <p:cNvPr id="8" name="Rounded Rectangle 7"/>
+          <p:cNvPr id="9" name="Rounded Rectangle 8"/>
           <p:cNvSpPr/>
           <p:nvPr/>
         </p:nvSpPr>

</xml_diff>